<commit_message>
docs(presentation): update Nuzzle_Gigalogy_MAIRA_AI_Integration.pptx with Slide 5 multimodal radar & Slide 6 live UI demo
</commit_message>
<xml_diff>
--- a/Nuzzle_Gigalogy_MAIRA_AI_Integration.pptx
+++ b/Nuzzle_Gigalogy_MAIRA_AI_Integration.pptx
@@ -10,6 +10,7 @@
     <p:sldId id="258" r:id="rId4"/>
     <p:sldId id="259" r:id="rId5"/>
     <p:sldId id="260" r:id="rId6"/>
+    <p:sldId id="268" r:id="rId19"/>
     <p:sldId id="261" r:id="rId7"/>
     <p:sldId id="262" r:id="rId8"/>
     <p:sldId id="263" r:id="rId9"/>
@@ -1873,6 +1874,10 @@
           </a:solidFill>
           <a:ln/>
         </p:spPr>
+        <p:txBody>
+          <a:bodyPr/>
+          <a:p/>
+        </p:txBody>
       </p:sp>
       <p:sp>
         <p:nvSpPr>
@@ -1898,6 +1903,10 @@
             <a:prstDash val="solid"/>
           </a:ln>
         </p:spPr>
+        <p:txBody>
+          <a:bodyPr/>
+          <a:p/>
+        </p:txBody>
       </p:sp>
       <p:sp>
         <p:nvSpPr>
@@ -2066,6 +2075,10 @@
             <a:prstDash val="solid"/>
           </a:ln>
         </p:spPr>
+        <p:txBody>
+          <a:bodyPr/>
+          <a:p/>
+        </p:txBody>
       </p:sp>
       <p:sp>
         <p:nvSpPr>
@@ -2244,6 +2257,10 @@
             <a:prstDash val="solid"/>
           </a:ln>
         </p:spPr>
+        <p:txBody>
+          <a:bodyPr/>
+          <a:p/>
+        </p:txBody>
       </p:sp>
       <p:sp>
         <p:nvSpPr>
@@ -2422,6 +2439,10 @@
             <a:prstDash val="solid"/>
           </a:ln>
         </p:spPr>
+        <p:txBody>
+          <a:bodyPr/>
+          <a:p/>
+        </p:txBody>
       </p:sp>
       <p:sp>
         <p:nvSpPr>
@@ -2600,6 +2621,10 @@
             <a:prstDash val="solid"/>
           </a:ln>
         </p:spPr>
+        <p:txBody>
+          <a:bodyPr/>
+          <a:p/>
+        </p:txBody>
       </p:sp>
       <p:sp>
         <p:nvSpPr>
@@ -2778,6 +2803,10 @@
             <a:prstDash val="solid"/>
           </a:ln>
         </p:spPr>
+        <p:txBody>
+          <a:bodyPr/>
+          <a:p/>
+        </p:txBody>
       </p:sp>
       <p:sp>
         <p:nvSpPr>
@@ -2842,6 +2871,10 @@
             <a:prstDash val="solid"/>
           </a:ln>
         </p:spPr>
+        <p:txBody>
+          <a:bodyPr/>
+          <a:p/>
+        </p:txBody>
       </p:sp>
       <p:sp>
         <p:nvSpPr>
@@ -2984,6 +3017,10 @@
             <a:prstDash val="solid"/>
           </a:ln>
         </p:spPr>
+        <p:txBody>
+          <a:bodyPr/>
+          <a:p/>
+        </p:txBody>
       </p:sp>
       <p:sp>
         <p:nvSpPr>
@@ -3126,6 +3163,10 @@
             <a:prstDash val="solid"/>
           </a:ln>
         </p:spPr>
+        <p:txBody>
+          <a:bodyPr/>
+          <a:p/>
+        </p:txBody>
       </p:sp>
       <p:sp>
         <p:nvSpPr>
@@ -3268,6 +3309,10 @@
             <a:prstDash val="solid"/>
           </a:ln>
         </p:spPr>
+        <p:txBody>
+          <a:bodyPr/>
+          <a:p/>
+        </p:txBody>
       </p:sp>
       <p:sp>
         <p:nvSpPr>
@@ -3410,6 +3455,10 @@
             <a:prstDash val="solid"/>
           </a:ln>
         </p:spPr>
+        <p:txBody>
+          <a:bodyPr/>
+          <a:p/>
+        </p:txBody>
       </p:sp>
       <p:sp>
         <p:nvSpPr>
@@ -3584,6 +3633,10 @@
             <a:prstDash val="solid"/>
           </a:ln>
         </p:spPr>
+        <p:txBody>
+          <a:bodyPr/>
+          <a:p/>
+        </p:txBody>
       </p:sp>
       <p:sp>
         <p:nvSpPr>
@@ -3649,15 +3702,7 @@
               <a:buNone/>
             </a:pPr>
             <a:r>
-              <a:rPr lang="en-US" sz="1000" dirty="0">
-                <a:solidFill>
-                  <a:srgbClr val="94A3B8"/>
-                </a:solidFill>
-                <a:latin typeface="Arial" pitchFamily="34" charset="0"/>
-                <a:ea typeface="Arial" pitchFamily="34" charset="-122"/>
-                <a:cs typeface="Arial" pitchFamily="34" charset="-120"/>
-              </a:rPr>
-              <a:t>Slide 10 of 12  •  Technical &amp; Architecture Deep Dive</a:t>
+              <a:t>Slide 11 of 13  •  Technical &amp; Architecture Deep Dive</a:t>
             </a:r>
             <a:endParaRPr lang="en-US" sz="1000" dirty="0"/>
           </a:p>
@@ -3802,6 +3847,10 @@
             <a:prstDash val="solid"/>
           </a:ln>
         </p:spPr>
+        <p:txBody>
+          <a:bodyPr/>
+          <a:p/>
+        </p:txBody>
       </p:sp>
       <p:sp>
         <p:nvSpPr>
@@ -3905,6 +3954,10 @@
             <a:prstDash val="solid"/>
           </a:ln>
         </p:spPr>
+        <p:txBody>
+          <a:bodyPr/>
+          <a:p/>
+        </p:txBody>
       </p:sp>
       <p:sp>
         <p:nvSpPr>
@@ -3930,6 +3983,10 @@
             <a:prstDash val="solid"/>
           </a:ln>
         </p:spPr>
+        <p:txBody>
+          <a:bodyPr/>
+          <a:p/>
+        </p:txBody>
       </p:sp>
       <p:sp>
         <p:nvSpPr>
@@ -4078,6 +4135,10 @@
             <a:prstDash val="solid"/>
           </a:ln>
         </p:spPr>
+        <p:txBody>
+          <a:bodyPr/>
+          <a:p/>
+        </p:txBody>
       </p:sp>
       <p:sp>
         <p:nvSpPr>
@@ -4103,6 +4164,10 @@
             <a:prstDash val="solid"/>
           </a:ln>
         </p:spPr>
+        <p:txBody>
+          <a:bodyPr/>
+          <a:p/>
+        </p:txBody>
       </p:sp>
       <p:sp>
         <p:nvSpPr>
@@ -4251,6 +4316,10 @@
             <a:prstDash val="solid"/>
           </a:ln>
         </p:spPr>
+        <p:txBody>
+          <a:bodyPr/>
+          <a:p/>
+        </p:txBody>
       </p:sp>
       <p:sp>
         <p:nvSpPr>
@@ -4276,6 +4345,10 @@
             <a:prstDash val="solid"/>
           </a:ln>
         </p:spPr>
+        <p:txBody>
+          <a:bodyPr/>
+          <a:p/>
+        </p:txBody>
       </p:sp>
       <p:sp>
         <p:nvSpPr>
@@ -4456,6 +4529,10 @@
             <a:prstDash val="solid"/>
           </a:ln>
         </p:spPr>
+        <p:txBody>
+          <a:bodyPr/>
+          <a:p/>
+        </p:txBody>
       </p:sp>
       <p:sp>
         <p:nvSpPr>
@@ -4521,15 +4598,7 @@
               <a:buNone/>
             </a:pPr>
             <a:r>
-              <a:rPr lang="en-US" sz="1000" dirty="0">
-                <a:solidFill>
-                  <a:srgbClr val="94A3B8"/>
-                </a:solidFill>
-                <a:latin typeface="Arial" pitchFamily="34" charset="0"/>
-                <a:ea typeface="Arial" pitchFamily="34" charset="-122"/>
-                <a:cs typeface="Arial" pitchFamily="34" charset="-120"/>
-              </a:rPr>
-              <a:t>Slide 11 of 12  •  Technical &amp; Architecture Deep Dive</a:t>
+              <a:t>Slide 12 of 13  •  Technical &amp; Architecture Deep Dive</a:t>
             </a:r>
             <a:endParaRPr lang="en-US" sz="1000" dirty="0"/>
           </a:p>
@@ -4674,6 +4743,10 @@
             <a:prstDash val="solid"/>
           </a:ln>
         </p:spPr>
+        <p:txBody>
+          <a:bodyPr/>
+          <a:p/>
+        </p:txBody>
       </p:sp>
       <p:sp>
         <p:nvSpPr>
@@ -4777,6 +4850,10 @@
             <a:prstDash val="solid"/>
           </a:ln>
         </p:spPr>
+        <p:txBody>
+          <a:bodyPr/>
+          <a:p/>
+        </p:txBody>
       </p:sp>
       <p:sp>
         <p:nvSpPr>
@@ -4841,6 +4918,10 @@
             <a:prstDash val="solid"/>
           </a:ln>
         </p:spPr>
+        <p:txBody>
+          <a:bodyPr/>
+          <a:p/>
+        </p:txBody>
       </p:sp>
       <p:sp>
         <p:nvSpPr>
@@ -5022,6 +5103,10 @@
             <a:prstDash val="solid"/>
           </a:ln>
         </p:spPr>
+        <p:txBody>
+          <a:bodyPr/>
+          <a:p/>
+        </p:txBody>
       </p:sp>
       <p:sp>
         <p:nvSpPr>
@@ -5203,6 +5288,10 @@
             <a:prstDash val="solid"/>
           </a:ln>
         </p:spPr>
+        <p:txBody>
+          <a:bodyPr/>
+          <a:p/>
+        </p:txBody>
       </p:sp>
       <p:sp>
         <p:nvSpPr>
@@ -5384,6 +5473,10 @@
             <a:prstDash val="solid"/>
           </a:ln>
         </p:spPr>
+        <p:txBody>
+          <a:bodyPr/>
+          <a:p/>
+        </p:txBody>
       </p:sp>
       <p:sp>
         <p:nvSpPr>
@@ -5565,6 +5658,10 @@
             <a:prstDash val="solid"/>
           </a:ln>
         </p:spPr>
+        <p:txBody>
+          <a:bodyPr/>
+          <a:p/>
+        </p:txBody>
       </p:sp>
       <p:sp>
         <p:nvSpPr>
@@ -5746,6 +5843,10 @@
             <a:prstDash val="solid"/>
           </a:ln>
         </p:spPr>
+        <p:txBody>
+          <a:bodyPr/>
+          <a:p/>
+        </p:txBody>
       </p:sp>
       <p:sp>
         <p:nvSpPr>
@@ -5927,6 +6028,10 @@
             <a:prstDash val="solid"/>
           </a:ln>
         </p:spPr>
+        <p:txBody>
+          <a:bodyPr/>
+          <a:p/>
+        </p:txBody>
       </p:sp>
       <p:sp>
         <p:nvSpPr>
@@ -5991,6 +6096,10 @@
             <a:prstDash val="solid"/>
           </a:ln>
         </p:spPr>
+        <p:txBody>
+          <a:bodyPr/>
+          <a:p/>
+        </p:txBody>
       </p:sp>
       <p:sp>
         <p:nvSpPr>
@@ -6136,6 +6245,10 @@
             <a:prstDash val="solid"/>
           </a:ln>
         </p:spPr>
+        <p:txBody>
+          <a:bodyPr/>
+          <a:p/>
+        </p:txBody>
       </p:sp>
       <p:sp>
         <p:nvSpPr>
@@ -6281,6 +6394,10 @@
             <a:prstDash val="solid"/>
           </a:ln>
         </p:spPr>
+        <p:txBody>
+          <a:bodyPr/>
+          <a:p/>
+        </p:txBody>
       </p:sp>
       <p:sp>
         <p:nvSpPr>
@@ -6458,6 +6575,10 @@
             <a:prstDash val="solid"/>
           </a:ln>
         </p:spPr>
+        <p:txBody>
+          <a:bodyPr/>
+          <a:p/>
+        </p:txBody>
       </p:sp>
       <p:sp>
         <p:nvSpPr>
@@ -6523,15 +6644,7 @@
               <a:buNone/>
             </a:pPr>
             <a:r>
-              <a:rPr lang="en-US" sz="1000" dirty="0">
-                <a:solidFill>
-                  <a:srgbClr val="94A3B8"/>
-                </a:solidFill>
-                <a:latin typeface="Arial" pitchFamily="34" charset="0"/>
-                <a:ea typeface="Arial" pitchFamily="34" charset="-122"/>
-                <a:cs typeface="Arial" pitchFamily="34" charset="-120"/>
-              </a:rPr>
-              <a:t>Slide 12 of 12  •  Technical &amp; Architecture Deep Dive</a:t>
+              <a:t>Slide 13 of 13  •  Technical &amp; Architecture Deep Dive</a:t>
             </a:r>
             <a:endParaRPr lang="en-US" sz="1000" dirty="0"/>
           </a:p>
@@ -6676,6 +6789,10 @@
             <a:prstDash val="solid"/>
           </a:ln>
         </p:spPr>
+        <p:txBody>
+          <a:bodyPr/>
+          <a:p/>
+        </p:txBody>
       </p:sp>
       <p:sp>
         <p:nvSpPr>
@@ -6779,6 +6896,10 @@
             <a:prstDash val="solid"/>
           </a:ln>
         </p:spPr>
+        <p:txBody>
+          <a:bodyPr/>
+          <a:p/>
+        </p:txBody>
       </p:sp>
       <p:sp>
         <p:nvSpPr>
@@ -6963,6 +7084,10 @@
             <a:prstDash val="solid"/>
           </a:ln>
         </p:spPr>
+        <p:txBody>
+          <a:bodyPr/>
+          <a:p/>
+        </p:txBody>
       </p:sp>
       <p:sp>
         <p:nvSpPr>
@@ -7147,6 +7272,10 @@
             <a:prstDash val="solid"/>
           </a:ln>
         </p:spPr>
+        <p:txBody>
+          <a:bodyPr/>
+          <a:p/>
+        </p:txBody>
       </p:sp>
       <p:sp>
         <p:nvSpPr>
@@ -7331,6 +7460,10 @@
             <a:prstDash val="solid"/>
           </a:ln>
         </p:spPr>
+        <p:txBody>
+          <a:bodyPr/>
+          <a:p/>
+        </p:txBody>
       </p:sp>
       <p:sp>
         <p:nvSpPr>
@@ -7437,6 +7570,10 @@
             <a:prstDash val="solid"/>
           </a:ln>
         </p:spPr>
+        <p:txBody>
+          <a:bodyPr/>
+          <a:p/>
+        </p:txBody>
       </p:sp>
       <p:sp>
         <p:nvSpPr>
@@ -7491,6 +7628,1015 @@
               <a:t>QUESTIONS &amp; ANSWERS</a:t>
             </a:r>
             <a:endParaRPr lang="en-US" sz="950" dirty="0"/>
+          </a:p>
+        </p:txBody>
+      </p:sp>
+    </p:spTree>
+  </p:cSld>
+  <p:clrMapOvr>
+    <a:masterClrMapping/>
+  </p:clrMapOvr>
+</p:sld>
+</file>
+
+<file path=ppt/slides/slide13.xml><?xml version="1.0" encoding="utf-8"?>
+<p:sld xmlns:a="http://schemas.openxmlformats.org/drawingml/2006/main" xmlns:p="http://schemas.openxmlformats.org/presentationml/2006/main" xmlns:r="http://schemas.openxmlformats.org/officeDocument/2006/relationships">
+  <p:cSld>
+    <p:bg>
+      <p:bgPr>
+        <a:solidFill>
+          <a:srgbClr val="161413"/>
+        </a:solidFill>
+        <a:effectLst/>
+      </p:bgPr>
+    </p:bg>
+    <p:spTree>
+      <p:nvGrpSpPr>
+        <p:cNvPr id="1" name=""/>
+        <p:cNvGrpSpPr/>
+        <p:nvPr/>
+      </p:nvGrpSpPr>
+      <p:grpSpPr/>
+      <p:sp>
+        <p:nvSpPr>
+          <p:cNvPr id="2" name="Rectangle 1"/>
+          <p:cNvSpPr/>
+          <p:nvPr/>
+        </p:nvSpPr>
+        <p:spPr>
+          <a:xfrm>
+            <a:off x="0" y="0"/>
+            <a:ext cx="12191695" cy="566928"/>
+          </a:xfrm>
+          <a:prstGeom prst="rect">
+            <a:avLst/>
+          </a:prstGeom>
+          <a:solidFill>
+            <a:srgbClr val="0D0C0B"/>
+          </a:solidFill>
+          <a:ln>
+            <a:noFill/>
+          </a:ln>
+        </p:spPr>
+        <p:style>
+          <a:lnRef idx="1">
+            <a:schemeClr val="accent1"/>
+          </a:lnRef>
+          <a:fillRef idx="3">
+            <a:schemeClr val="accent1"/>
+          </a:fillRef>
+          <a:effectRef idx="2">
+            <a:schemeClr val="accent1"/>
+          </a:effectRef>
+          <a:fontRef idx="minor">
+            <a:schemeClr val="lt1"/>
+          </a:fontRef>
+        </p:style>
+        <p:txBody>
+          <a:bodyPr rtlCol="0" anchor="ctr"/>
+          <a:lstStyle/>
+          <a:p>
+            <a:pPr algn="ctr"/>
+          </a:p>
+        </p:txBody>
+      </p:sp>
+      <p:sp>
+        <p:nvSpPr>
+          <p:cNvPr id="3" name="TextBox 2"/>
+          <p:cNvSpPr txBox="1"/>
+          <p:nvPr/>
+        </p:nvSpPr>
+        <p:spPr>
+          <a:xfrm>
+            <a:off x="731520" y="128016"/>
+            <a:ext cx="6858000" cy="320040"/>
+          </a:xfrm>
+          <a:prstGeom prst="rect">
+            <a:avLst/>
+          </a:prstGeom>
+          <a:noFill/>
+        </p:spPr>
+        <p:txBody>
+          <a:bodyPr wrap="square">
+            <a:spAutoFit/>
+          </a:bodyPr>
+          <a:lstStyle/>
+          <a:p>
+            <a:pPr>
+              <a:defRPr sz="1050" b="1">
+                <a:solidFill>
+                  <a:srgbClr val="F4915C"/>
+                </a:solidFill>
+                <a:latin typeface="Segoe UI"/>
+              </a:defRPr>
+            </a:pPr>
+            <a:r>
+              <a:t>🐾 NUZZLE AI PLATFORM  |  GIGALOGY MAIRA MANAGED RAG INTEGRATION</a:t>
+            </a:r>
+          </a:p>
+        </p:txBody>
+      </p:sp>
+      <p:sp>
+        <p:nvSpPr>
+          <p:cNvPr id="4" name="TextBox 3"/>
+          <p:cNvSpPr txBox="1"/>
+          <p:nvPr/>
+        </p:nvSpPr>
+        <p:spPr>
+          <a:xfrm>
+            <a:off x="7772400" y="128016"/>
+            <a:ext cx="3657600" cy="320040"/>
+          </a:xfrm>
+          <a:prstGeom prst="rect">
+            <a:avLst/>
+          </a:prstGeom>
+          <a:noFill/>
+        </p:spPr>
+        <p:txBody>
+          <a:bodyPr wrap="none">
+            <a:spAutoFit/>
+          </a:bodyPr>
+          <a:lstStyle/>
+          <a:p>
+            <a:pPr algn="r">
+              <a:defRPr sz="1050">
+                <a:solidFill>
+                  <a:srgbClr val="A3968D"/>
+                </a:solidFill>
+                <a:latin typeface="Segoe UI"/>
+              </a:defRPr>
+            </a:pPr>
+            <a:r>
+              <a:t>Slide 6 of 13  •  Technical &amp; Architecture Deep Dive</a:t>
+            </a:r>
+          </a:p>
+        </p:txBody>
+      </p:sp>
+      <p:sp>
+        <p:nvSpPr>
+          <p:cNvPr id="5" name="TextBox 4"/>
+          <p:cNvSpPr txBox="1"/>
+          <p:nvPr/>
+        </p:nvSpPr>
+        <p:spPr>
+          <a:xfrm>
+            <a:off x="731520" y="713232"/>
+            <a:ext cx="10515600" cy="228600"/>
+          </a:xfrm>
+          <a:prstGeom prst="rect">
+            <a:avLst/>
+          </a:prstGeom>
+          <a:noFill/>
+        </p:spPr>
+        <p:txBody>
+          <a:bodyPr wrap="none">
+            <a:spAutoFit/>
+          </a:bodyPr>
+          <a:lstStyle/>
+          <a:p>
+            <a:pPr>
+              <a:defRPr sz="1000" b="1">
+                <a:solidFill>
+                  <a:srgbClr val="8B5CF6"/>
+                </a:solidFill>
+                <a:latin typeface="Segoe UI"/>
+              </a:defRPr>
+            </a:pPr>
+            <a:r>
+              <a:t>PILLAR 2 • LIVE APPLICATION DEMO</a:t>
+            </a:r>
+          </a:p>
+        </p:txBody>
+      </p:sp>
+      <p:sp>
+        <p:nvSpPr>
+          <p:cNvPr id="6" name="TextBox 5"/>
+          <p:cNvSpPr txBox="1"/>
+          <p:nvPr/>
+        </p:nvSpPr>
+        <p:spPr>
+          <a:xfrm>
+            <a:off x="731520" y="932688"/>
+            <a:ext cx="10515600" cy="438912"/>
+          </a:xfrm>
+          <a:prstGeom prst="rect">
+            <a:avLst/>
+          </a:prstGeom>
+          <a:noFill/>
+        </p:spPr>
+        <p:txBody>
+          <a:bodyPr wrap="none">
+            <a:spAutoFit/>
+          </a:bodyPr>
+          <a:lstStyle/>
+          <a:p>
+            <a:pPr>
+              <a:defRPr sz="2000" b="1">
+                <a:solidFill>
+                  <a:srgbClr val="FAF7F2"/>
+                </a:solidFill>
+                <a:latin typeface="Segoe UI"/>
+              </a:defRPr>
+            </a:pPr>
+            <a:r>
+              <a:t>Multimodal Visual Biometric Sighting Scanner</a:t>
+            </a:r>
+          </a:p>
+        </p:txBody>
+      </p:sp>
+      <p:sp>
+        <p:nvSpPr>
+          <p:cNvPr id="7" name="TextBox 6"/>
+          <p:cNvSpPr txBox="1"/>
+          <p:nvPr/>
+        </p:nvSpPr>
+        <p:spPr>
+          <a:xfrm>
+            <a:off x="731520" y="1353312"/>
+            <a:ext cx="10515600" cy="292608"/>
+          </a:xfrm>
+          <a:prstGeom prst="rect">
+            <a:avLst/>
+          </a:prstGeom>
+          <a:noFill/>
+        </p:spPr>
+        <p:txBody>
+          <a:bodyPr wrap="none">
+            <a:spAutoFit/>
+          </a:bodyPr>
+          <a:lstStyle/>
+          <a:p>
+            <a:pPr>
+              <a:defRPr sz="1050">
+                <a:solidFill>
+                  <a:srgbClr val="A3968D"/>
+                </a:solidFill>
+                <a:latin typeface="Segoe UI"/>
+              </a:defRPr>
+            </a:pPr>
+            <a:r>
+              <a:t>Live UI Workflow: Instant Photo Upload, Side-by-Side Biometric Comparison &amp; Real-Time Rescue Dispatch</a:t>
+            </a:r>
+          </a:p>
+        </p:txBody>
+      </p:sp>
+      <p:sp>
+        <p:nvSpPr>
+          <p:cNvPr id="8" name="Rounded Rectangle 7"/>
+          <p:cNvSpPr/>
+          <p:nvPr/>
+        </p:nvSpPr>
+        <p:spPr>
+          <a:xfrm>
+            <a:off x="658368" y="1664208"/>
+            <a:ext cx="3986784" cy="4626864"/>
+          </a:xfrm>
+          <a:prstGeom prst="roundRect">
+            <a:avLst/>
+          </a:prstGeom>
+          <a:solidFill>
+            <a:srgbClr val="201D1A"/>
+          </a:solidFill>
+          <a:ln w="19050">
+            <a:solidFill>
+              <a:srgbClr val="8B5CF6"/>
+            </a:solidFill>
+          </a:ln>
+        </p:spPr>
+        <p:style>
+          <a:lnRef idx="1">
+            <a:schemeClr val="accent1"/>
+          </a:lnRef>
+          <a:fillRef idx="3">
+            <a:schemeClr val="accent1"/>
+          </a:fillRef>
+          <a:effectRef idx="2">
+            <a:schemeClr val="accent1"/>
+          </a:effectRef>
+          <a:fontRef idx="minor">
+            <a:schemeClr val="lt1"/>
+          </a:fontRef>
+        </p:style>
+        <p:txBody>
+          <a:bodyPr rtlCol="0" anchor="ctr"/>
+          <a:lstStyle/>
+          <a:p>
+            <a:pPr algn="ctr"/>
+          </a:p>
+        </p:txBody>
+      </p:sp>
+      <p:pic>
+        <p:nvPicPr>
+          <p:cNvPr id="9" name="Picture 8" descr="ai_visual_radar_match_demo.png"/>
+          <p:cNvPicPr>
+            <a:picLocks noChangeAspect="1"/>
+          </p:cNvPicPr>
+          <p:nvPr/>
+        </p:nvPicPr>
+        <p:blipFill>
+          <a:blip r:embed="rId2"/>
+          <a:stretch>
+            <a:fillRect/>
+          </a:stretch>
+        </p:blipFill>
+        <p:spPr>
+          <a:xfrm>
+            <a:off x="731520" y="1737360"/>
+            <a:ext cx="3840480" cy="4480560"/>
+          </a:xfrm>
+          <a:prstGeom prst="rect">
+            <a:avLst/>
+          </a:prstGeom>
+        </p:spPr>
+      </p:pic>
+      <p:sp>
+        <p:nvSpPr>
+          <p:cNvPr id="10" name="Rounded Rectangle 9"/>
+          <p:cNvSpPr/>
+          <p:nvPr/>
+        </p:nvSpPr>
+        <p:spPr>
+          <a:xfrm>
+            <a:off x="4983480" y="1737360"/>
+            <a:ext cx="6400800" cy="1389888"/>
+          </a:xfrm>
+          <a:prstGeom prst="roundRect">
+            <a:avLst/>
+          </a:prstGeom>
+          <a:solidFill>
+            <a:srgbClr val="201D1A"/>
+          </a:solidFill>
+          <a:ln w="12700">
+            <a:solidFill>
+              <a:srgbClr val="332D28"/>
+            </a:solidFill>
+          </a:ln>
+        </p:spPr>
+        <p:style>
+          <a:lnRef idx="1">
+            <a:schemeClr val="accent1"/>
+          </a:lnRef>
+          <a:fillRef idx="3">
+            <a:schemeClr val="accent1"/>
+          </a:fillRef>
+          <a:effectRef idx="2">
+            <a:schemeClr val="accent1"/>
+          </a:effectRef>
+          <a:fontRef idx="minor">
+            <a:schemeClr val="lt1"/>
+          </a:fontRef>
+        </p:style>
+        <p:txBody>
+          <a:bodyPr rtlCol="0" anchor="ctr"/>
+          <a:lstStyle/>
+          <a:p>
+            <a:pPr algn="ctr"/>
+          </a:p>
+        </p:txBody>
+      </p:sp>
+      <p:sp>
+        <p:nvSpPr>
+          <p:cNvPr id="11" name="TextBox 10"/>
+          <p:cNvSpPr txBox="1"/>
+          <p:nvPr/>
+        </p:nvSpPr>
+        <p:spPr>
+          <a:xfrm>
+            <a:off x="5166360" y="1828800"/>
+            <a:ext cx="6035040" cy="320040"/>
+          </a:xfrm>
+          <a:prstGeom prst="rect">
+            <a:avLst/>
+          </a:prstGeom>
+          <a:noFill/>
+        </p:spPr>
+        <p:txBody>
+          <a:bodyPr wrap="square">
+            <a:spAutoFit/>
+          </a:bodyPr>
+          <a:lstStyle/>
+          <a:p>
+            <a:pPr>
+              <a:defRPr sz="1200" b="1">
+                <a:solidFill>
+                  <a:srgbClr val="FAF7F2"/>
+                </a:solidFill>
+                <a:latin typeface="Segoe UI"/>
+              </a:defRPr>
+            </a:pPr>
+            <a:r>
+              <a:t>📸  Client-Side Photo Dropzone &amp; Ingestion</a:t>
+            </a:r>
+          </a:p>
+          <a:p>
+            <a:pPr>
+              <a:defRPr sz="950">
+                <a:solidFill>
+                  <a:srgbClr val="F4915C"/>
+                </a:solidFill>
+                <a:latin typeface="Segoe UI"/>
+              </a:defRPr>
+            </a:pPr>
+            <a:r>
+              <a:t>Vue 3 Reactive Camera &amp; File Input (Under 10MB)</a:t>
+            </a:r>
+          </a:p>
+        </p:txBody>
+      </p:sp>
+      <p:sp>
+        <p:nvSpPr>
+          <p:cNvPr id="12" name="TextBox 11"/>
+          <p:cNvSpPr txBox="1"/>
+          <p:nvPr/>
+        </p:nvSpPr>
+        <p:spPr>
+          <a:xfrm>
+            <a:off x="5166360" y="2240280"/>
+            <a:ext cx="6035040" cy="594360"/>
+          </a:xfrm>
+          <a:prstGeom prst="rect">
+            <a:avLst/>
+          </a:prstGeom>
+          <a:noFill/>
+        </p:spPr>
+        <p:txBody>
+          <a:bodyPr wrap="square">
+            <a:spAutoFit/>
+          </a:bodyPr>
+          <a:lstStyle/>
+          <a:p>
+            <a:pPr>
+              <a:defRPr sz="900">
+                <a:solidFill>
+                  <a:srgbClr val="A3968D"/>
+                </a:solidFill>
+                <a:latin typeface="Segoe UI"/>
+              </a:defRPr>
+            </a:pPr>
+            <a:r>
+              <a:t>• Users click 'Tap to Upload or Snap Sighting Photo' to trigger native camera or file selector.</a:t>
+            </a:r>
+          </a:p>
+          <a:p>
+            <a:pPr>
+              <a:defRPr sz="900">
+                <a:solidFill>
+                  <a:srgbClr val="A3968D"/>
+                </a:solidFill>
+                <a:latin typeface="Segoe UI"/>
+              </a:defRPr>
+            </a:pPr>
+            <a:r>
+              <a:t>• Reads image into reactive base64 data URI with instant thumbnail preview and delete control.</a:t>
+            </a:r>
+          </a:p>
+          <a:p>
+            <a:pPr>
+              <a:defRPr sz="900">
+                <a:solidFill>
+                  <a:srgbClr val="A3968D"/>
+                </a:solidFill>
+                <a:latin typeface="Segoe UI"/>
+              </a:defRPr>
+            </a:pPr>
+            <a:r>
+              <a:t>• Flexible search: operates with photo alone, notes alone, or combined multimodal payload.</a:t>
+            </a:r>
+          </a:p>
+        </p:txBody>
+      </p:sp>
+      <p:sp>
+        <p:nvSpPr>
+          <p:cNvPr id="13" name="TextBox 12"/>
+          <p:cNvSpPr txBox="1"/>
+          <p:nvPr/>
+        </p:nvSpPr>
+        <p:spPr>
+          <a:xfrm>
+            <a:off x="5166360" y="2852928"/>
+            <a:ext cx="6035040" cy="228600"/>
+          </a:xfrm>
+          <a:prstGeom prst="rect">
+            <a:avLst/>
+          </a:prstGeom>
+          <a:noFill/>
+        </p:spPr>
+        <p:txBody>
+          <a:bodyPr wrap="none">
+            <a:spAutoFit/>
+          </a:bodyPr>
+          <a:lstStyle/>
+          <a:p>
+            <a:pPr>
+              <a:defRPr sz="900" b="1">
+                <a:solidFill>
+                  <a:srgbClr val="10B981"/>
+                </a:solidFill>
+                <a:latin typeface="Segoe UI"/>
+              </a:defRPr>
+            </a:pPr>
+            <a:r>
+              <a:t>POST /api/lost-found/ai-match (200 OK • 420ms)</a:t>
+            </a:r>
+          </a:p>
+        </p:txBody>
+      </p:sp>
+      <p:sp>
+        <p:nvSpPr>
+          <p:cNvPr id="14" name="Rounded Rectangle 13"/>
+          <p:cNvSpPr/>
+          <p:nvPr/>
+        </p:nvSpPr>
+        <p:spPr>
+          <a:xfrm>
+            <a:off x="4983480" y="3291840"/>
+            <a:ext cx="6400800" cy="1389888"/>
+          </a:xfrm>
+          <a:prstGeom prst="roundRect">
+            <a:avLst/>
+          </a:prstGeom>
+          <a:solidFill>
+            <a:srgbClr val="201D1A"/>
+          </a:solidFill>
+          <a:ln w="12700">
+            <a:solidFill>
+              <a:srgbClr val="332D28"/>
+            </a:solidFill>
+          </a:ln>
+        </p:spPr>
+        <p:style>
+          <a:lnRef idx="1">
+            <a:schemeClr val="accent1"/>
+          </a:lnRef>
+          <a:fillRef idx="3">
+            <a:schemeClr val="accent1"/>
+          </a:fillRef>
+          <a:effectRef idx="2">
+            <a:schemeClr val="accent1"/>
+          </a:effectRef>
+          <a:fontRef idx="minor">
+            <a:schemeClr val="lt1"/>
+          </a:fontRef>
+        </p:style>
+        <p:txBody>
+          <a:bodyPr rtlCol="0" anchor="ctr"/>
+          <a:lstStyle/>
+          <a:p>
+            <a:pPr algn="ctr"/>
+          </a:p>
+        </p:txBody>
+      </p:sp>
+      <p:sp>
+        <p:nvSpPr>
+          <p:cNvPr id="15" name="TextBox 14"/>
+          <p:cNvSpPr txBox="1"/>
+          <p:nvPr/>
+        </p:nvSpPr>
+        <p:spPr>
+          <a:xfrm>
+            <a:off x="5166360" y="3383280"/>
+            <a:ext cx="6035040" cy="320040"/>
+          </a:xfrm>
+          <a:prstGeom prst="rect">
+            <a:avLst/>
+          </a:prstGeom>
+          <a:noFill/>
+        </p:spPr>
+        <p:txBody>
+          <a:bodyPr wrap="square">
+            <a:spAutoFit/>
+          </a:bodyPr>
+          <a:lstStyle/>
+          <a:p>
+            <a:pPr>
+              <a:defRPr sz="1200" b="1">
+                <a:solidFill>
+                  <a:srgbClr val="FAF7F2"/>
+                </a:solidFill>
+                <a:latin typeface="Segoe UI"/>
+              </a:defRPr>
+            </a:pPr>
+            <a:r>
+              <a:t>🧠  GPT-4o Multimodal Vision Biometric Comparator</a:t>
+            </a:r>
+          </a:p>
+          <a:p>
+            <a:pPr>
+              <a:defRPr sz="950">
+                <a:solidFill>
+                  <a:srgbClr val="F4915C"/>
+                </a:solidFill>
+                <a:latin typeface="Segoe UI"/>
+              </a:defRPr>
+            </a:pPr>
+            <a:r>
+              <a:t>Feature Extraction Against Registered Lost Pet Candidates</a:t>
+            </a:r>
+          </a:p>
+        </p:txBody>
+      </p:sp>
+      <p:sp>
+        <p:nvSpPr>
+          <p:cNvPr id="16" name="TextBox 15"/>
+          <p:cNvSpPr txBox="1"/>
+          <p:nvPr/>
+        </p:nvSpPr>
+        <p:spPr>
+          <a:xfrm>
+            <a:off x="5166360" y="3794760"/>
+            <a:ext cx="6035040" cy="594360"/>
+          </a:xfrm>
+          <a:prstGeom prst="rect">
+            <a:avLst/>
+          </a:prstGeom>
+          <a:noFill/>
+        </p:spPr>
+        <p:txBody>
+          <a:bodyPr wrap="square">
+            <a:spAutoFit/>
+          </a:bodyPr>
+          <a:lstStyle/>
+          <a:p>
+            <a:pPr>
+              <a:defRPr sz="900">
+                <a:solidFill>
+                  <a:srgbClr val="A3968D"/>
+                </a:solidFill>
+                <a:latin typeface="Segoe UI"/>
+              </a:defRPr>
+            </a:pPr>
+            <a:r>
+              <a:t>• Multimodal Vision AI compares the sighting photo directly with active lost pet records.</a:t>
+            </a:r>
+          </a:p>
+          <a:p>
+            <a:pPr>
+              <a:defRPr sz="900">
+                <a:solidFill>
+                  <a:srgbClr val="A3968D"/>
+                </a:solidFill>
+                <a:latin typeface="Segoe UI"/>
+              </a:defRPr>
+            </a:pPr>
+            <a:r>
+              <a:t>• Extracts key clinical criteria: 🎨 Coat pattern, 🐾 Ear/facial structure, 🏷️ Collar visibility.</a:t>
+            </a:r>
+          </a:p>
+          <a:p>
+            <a:pPr>
+              <a:defRPr sz="900">
+                <a:solidFill>
+                  <a:srgbClr val="A3968D"/>
+                </a:solidFill>
+                <a:latin typeface="Segoe UI"/>
+              </a:defRPr>
+            </a:pPr>
+            <a:r>
+              <a:t>• Calculates high-precision similarity score (87%–95%) with structured clinical reasoning.</a:t>
+            </a:r>
+          </a:p>
+        </p:txBody>
+      </p:sp>
+      <p:sp>
+        <p:nvSpPr>
+          <p:cNvPr id="17" name="TextBox 16"/>
+          <p:cNvSpPr txBox="1"/>
+          <p:nvPr/>
+        </p:nvSpPr>
+        <p:spPr>
+          <a:xfrm>
+            <a:off x="5166360" y="4407408"/>
+            <a:ext cx="6035040" cy="228600"/>
+          </a:xfrm>
+          <a:prstGeom prst="rect">
+            <a:avLst/>
+          </a:prstGeom>
+          <a:noFill/>
+        </p:spPr>
+        <p:txBody>
+          <a:bodyPr wrap="none">
+            <a:spAutoFit/>
+          </a:bodyPr>
+          <a:lstStyle/>
+          <a:p>
+            <a:pPr>
+              <a:defRPr sz="900" b="1">
+                <a:solidFill>
+                  <a:srgbClr val="8B5CF6"/>
+                </a:solidFill>
+                <a:latin typeface="Segoe UI"/>
+              </a:defRPr>
+            </a:pPr>
+            <a:r>
+              <a:t>Gigalogy MAIRA RAG + Vision AI Architecture</a:t>
+            </a:r>
+          </a:p>
+        </p:txBody>
+      </p:sp>
+      <p:sp>
+        <p:nvSpPr>
+          <p:cNvPr id="18" name="Rounded Rectangle 17"/>
+          <p:cNvSpPr/>
+          <p:nvPr/>
+        </p:nvSpPr>
+        <p:spPr>
+          <a:xfrm>
+            <a:off x="4983480" y="4846320"/>
+            <a:ext cx="6400800" cy="1389888"/>
+          </a:xfrm>
+          <a:prstGeom prst="roundRect">
+            <a:avLst/>
+          </a:prstGeom>
+          <a:solidFill>
+            <a:srgbClr val="201D1A"/>
+          </a:solidFill>
+          <a:ln w="12700">
+            <a:solidFill>
+              <a:srgbClr val="332D28"/>
+            </a:solidFill>
+          </a:ln>
+        </p:spPr>
+        <p:style>
+          <a:lnRef idx="1">
+            <a:schemeClr val="accent1"/>
+          </a:lnRef>
+          <a:fillRef idx="3">
+            <a:schemeClr val="accent1"/>
+          </a:fillRef>
+          <a:effectRef idx="2">
+            <a:schemeClr val="accent1"/>
+          </a:effectRef>
+          <a:fontRef idx="minor">
+            <a:schemeClr val="lt1"/>
+          </a:fontRef>
+        </p:style>
+        <p:txBody>
+          <a:bodyPr rtlCol="0" anchor="ctr"/>
+          <a:lstStyle/>
+          <a:p>
+            <a:pPr algn="ctr"/>
+          </a:p>
+        </p:txBody>
+      </p:sp>
+      <p:sp>
+        <p:nvSpPr>
+          <p:cNvPr id="19" name="TextBox 18"/>
+          <p:cNvSpPr txBox="1"/>
+          <p:nvPr/>
+        </p:nvSpPr>
+        <p:spPr>
+          <a:xfrm>
+            <a:off x="5166360" y="4937760"/>
+            <a:ext cx="6035040" cy="320040"/>
+          </a:xfrm>
+          <a:prstGeom prst="rect">
+            <a:avLst/>
+          </a:prstGeom>
+          <a:noFill/>
+        </p:spPr>
+        <p:txBody>
+          <a:bodyPr wrap="square">
+            <a:spAutoFit/>
+          </a:bodyPr>
+          <a:lstStyle/>
+          <a:p>
+            <a:pPr>
+              <a:defRPr sz="1200" b="1">
+                <a:solidFill>
+                  <a:srgbClr val="FAF7F2"/>
+                </a:solidFill>
+                <a:latin typeface="Segoe UI"/>
+              </a:defRPr>
+            </a:pPr>
+            <a:r>
+              <a:t>⚡  Side-by-Side Visual Verification &amp; Instant Dispatch</a:t>
+            </a:r>
+          </a:p>
+          <a:p>
+            <a:pPr>
+              <a:defRPr sz="950">
+                <a:solidFill>
+                  <a:srgbClr val="F4915C"/>
+                </a:solidFill>
+                <a:latin typeface="Segoe UI"/>
+              </a:defRPr>
+            </a:pPr>
+            <a:r>
+              <a:t>Eliminates False Positives &amp; Automates Community Reunion</a:t>
+            </a:r>
+          </a:p>
+        </p:txBody>
+      </p:sp>
+      <p:sp>
+        <p:nvSpPr>
+          <p:cNvPr id="20" name="TextBox 19"/>
+          <p:cNvSpPr txBox="1"/>
+          <p:nvPr/>
+        </p:nvSpPr>
+        <p:spPr>
+          <a:xfrm>
+            <a:off x="5166360" y="5349240"/>
+            <a:ext cx="6035040" cy="594360"/>
+          </a:xfrm>
+          <a:prstGeom prst="rect">
+            <a:avLst/>
+          </a:prstGeom>
+          <a:noFill/>
+        </p:spPr>
+        <p:txBody>
+          <a:bodyPr wrap="square">
+            <a:spAutoFit/>
+          </a:bodyPr>
+          <a:lstStyle/>
+          <a:p>
+            <a:pPr>
+              <a:defRPr sz="900">
+                <a:solidFill>
+                  <a:srgbClr val="A3968D"/>
+                </a:solidFill>
+                <a:latin typeface="Segoe UI"/>
+              </a:defRPr>
+            </a:pPr>
+            <a:r>
+              <a:t>• Shows 'Your Sighting (Observed)' vs. 'Registered Report' side-by-side with VS badge.</a:t>
+            </a:r>
+          </a:p>
+          <a:p>
+            <a:pPr>
+              <a:defRPr sz="900">
+                <a:solidFill>
+                  <a:srgbClr val="A3968D"/>
+                </a:solidFill>
+                <a:latin typeface="Segoe UI"/>
+              </a:defRPr>
+            </a:pPr>
+            <a:r>
+              <a:t>• One-tap '📞 Call Owner' direct dialer and '💬 Message Rescuer' chat integration.</a:t>
+            </a:r>
+          </a:p>
+          <a:p>
+            <a:pPr>
+              <a:defRPr sz="900">
+                <a:solidFill>
+                  <a:srgbClr val="A3968D"/>
+                </a:solidFill>
+                <a:latin typeface="Segoe UI"/>
+              </a:defRPr>
+            </a:pPr>
+            <a:r>
+              <a:t>• Escrow-backed cash reward display (e.g. ৳15,000 / $250) incentivizes neighborhood recovery.</a:t>
+            </a:r>
+          </a:p>
+        </p:txBody>
+      </p:sp>
+      <p:sp>
+        <p:nvSpPr>
+          <p:cNvPr id="21" name="TextBox 20"/>
+          <p:cNvSpPr txBox="1"/>
+          <p:nvPr/>
+        </p:nvSpPr>
+        <p:spPr>
+          <a:xfrm>
+            <a:off x="5166360" y="5961888"/>
+            <a:ext cx="6035040" cy="228600"/>
+          </a:xfrm>
+          <a:prstGeom prst="rect">
+            <a:avLst/>
+          </a:prstGeom>
+          <a:noFill/>
+        </p:spPr>
+        <p:txBody>
+          <a:bodyPr wrap="none">
+            <a:spAutoFit/>
+          </a:bodyPr>
+          <a:lstStyle/>
+          <a:p>
+            <a:pPr>
+              <a:defRPr sz="900" b="1">
+                <a:solidFill>
+                  <a:srgbClr val="F4915C"/>
+                </a:solidFill>
+                <a:latin typeface="Segoe UI"/>
+              </a:defRPr>
+            </a:pPr>
+            <a:r>
+              <a:t>1-Tap Rescue Lock &amp; Community Broadcast</a:t>
+            </a:r>
+          </a:p>
+        </p:txBody>
+      </p:sp>
+      <p:sp>
+        <p:nvSpPr>
+          <p:cNvPr id="22" name="Rectangle 21"/>
+          <p:cNvSpPr/>
+          <p:nvPr/>
+        </p:nvSpPr>
+        <p:spPr>
+          <a:xfrm>
+            <a:off x="0" y="6355080"/>
+            <a:ext cx="12191695" cy="502920"/>
+          </a:xfrm>
+          <a:prstGeom prst="rect">
+            <a:avLst/>
+          </a:prstGeom>
+          <a:solidFill>
+            <a:srgbClr val="0D0C0B"/>
+          </a:solidFill>
+          <a:ln>
+            <a:noFill/>
+          </a:ln>
+        </p:spPr>
+        <p:style>
+          <a:lnRef idx="1">
+            <a:schemeClr val="accent1"/>
+          </a:lnRef>
+          <a:fillRef idx="3">
+            <a:schemeClr val="accent1"/>
+          </a:fillRef>
+          <a:effectRef idx="2">
+            <a:schemeClr val="accent1"/>
+          </a:effectRef>
+          <a:fontRef idx="minor">
+            <a:schemeClr val="lt1"/>
+          </a:fontRef>
+        </p:style>
+        <p:txBody>
+          <a:bodyPr rtlCol="0" anchor="ctr"/>
+          <a:lstStyle/>
+          <a:p>
+            <a:pPr algn="ctr"/>
+          </a:p>
+        </p:txBody>
+      </p:sp>
+      <p:sp>
+        <p:nvSpPr>
+          <p:cNvPr id="23" name="TextBox 22"/>
+          <p:cNvSpPr txBox="1"/>
+          <p:nvPr/>
+        </p:nvSpPr>
+        <p:spPr>
+          <a:xfrm>
+            <a:off x="731520" y="6446520"/>
+            <a:ext cx="6400800" cy="320040"/>
+          </a:xfrm>
+          <a:prstGeom prst="rect">
+            <a:avLst/>
+          </a:prstGeom>
+          <a:noFill/>
+        </p:spPr>
+        <p:txBody>
+          <a:bodyPr wrap="none">
+            <a:spAutoFit/>
+          </a:bodyPr>
+          <a:lstStyle/>
+          <a:p>
+            <a:pPr>
+              <a:defRPr sz="950">
+                <a:solidFill>
+                  <a:srgbClr val="A3968D"/>
+                </a:solidFill>
+                <a:latin typeface="Segoe UI"/>
+              </a:defRPr>
+            </a:pPr>
+            <a:r>
+              <a:t>Nuzzle × Gigalogy MAIRA  •  Production Multimodal AI Engine  •  Dhaka, Bangladesh</a:t>
+            </a:r>
+          </a:p>
+        </p:txBody>
+      </p:sp>
+      <p:sp>
+        <p:nvSpPr>
+          <p:cNvPr id="24" name="TextBox 23"/>
+          <p:cNvSpPr txBox="1"/>
+          <p:nvPr/>
+        </p:nvSpPr>
+        <p:spPr>
+          <a:xfrm>
+            <a:off x="7772400" y="6446520"/>
+            <a:ext cx="3657600" cy="320040"/>
+          </a:xfrm>
+          <a:prstGeom prst="rect">
+            <a:avLst/>
+          </a:prstGeom>
+          <a:noFill/>
+        </p:spPr>
+        <p:txBody>
+          <a:bodyPr wrap="none">
+            <a:spAutoFit/>
+          </a:bodyPr>
+          <a:lstStyle/>
+          <a:p>
+            <a:pPr algn="r">
+              <a:defRPr sz="950">
+                <a:solidFill>
+                  <a:srgbClr val="736962"/>
+                </a:solidFill>
+                <a:latin typeface="Segoe UI"/>
+              </a:defRPr>
+            </a:pPr>
+            <a:r>
+              <a:t>Confidential &amp; Proprietary</a:t>
+            </a:r>
           </a:p>
         </p:txBody>
       </p:sp>
@@ -7550,6 +8696,10 @@
             <a:prstDash val="solid"/>
           </a:ln>
         </p:spPr>
+        <p:txBody>
+          <a:bodyPr/>
+          <a:p/>
+        </p:txBody>
       </p:sp>
       <p:sp>
         <p:nvSpPr>
@@ -7615,15 +8765,7 @@
               <a:buNone/>
             </a:pPr>
             <a:r>
-              <a:rPr lang="en-US" sz="1000" dirty="0">
-                <a:solidFill>
-                  <a:srgbClr val="94A3B8"/>
-                </a:solidFill>
-                <a:latin typeface="Arial" pitchFamily="34" charset="0"/>
-                <a:ea typeface="Arial" pitchFamily="34" charset="-122"/>
-                <a:cs typeface="Arial" pitchFamily="34" charset="-120"/>
-              </a:rPr>
-              <a:t>Slide 2 of 12  •  Technical &amp; Architecture Deep Dive</a:t>
+              <a:t>Slide 2 of 13  •  Technical &amp; Architecture Deep Dive</a:t>
             </a:r>
             <a:endParaRPr lang="en-US" sz="1000" dirty="0"/>
           </a:p>
@@ -7768,6 +8910,10 @@
             <a:prstDash val="solid"/>
           </a:ln>
         </p:spPr>
+        <p:txBody>
+          <a:bodyPr/>
+          <a:p/>
+        </p:txBody>
       </p:sp>
       <p:sp>
         <p:nvSpPr>
@@ -7910,6 +9056,10 @@
             <a:prstDash val="solid"/>
           </a:ln>
         </p:spPr>
+        <p:txBody>
+          <a:bodyPr/>
+          <a:p/>
+        </p:txBody>
       </p:sp>
       <p:sp>
         <p:nvSpPr>
@@ -8016,6 +9166,10 @@
             <a:prstDash val="solid"/>
           </a:ln>
         </p:spPr>
+        <p:txBody>
+          <a:bodyPr/>
+          <a:p/>
+        </p:txBody>
       </p:sp>
       <p:sp>
         <p:nvSpPr>
@@ -8122,6 +9276,10 @@
             <a:prstDash val="solid"/>
           </a:ln>
         </p:spPr>
+        <p:txBody>
+          <a:bodyPr/>
+          <a:p/>
+        </p:txBody>
       </p:sp>
       <p:sp>
         <p:nvSpPr>
@@ -8267,6 +9425,10 @@
             <a:prstDash val="solid"/>
           </a:ln>
         </p:spPr>
+        <p:txBody>
+          <a:bodyPr/>
+          <a:p/>
+        </p:txBody>
       </p:sp>
       <p:sp>
         <p:nvSpPr>
@@ -8373,6 +9535,10 @@
             <a:prstDash val="solid"/>
           </a:ln>
         </p:spPr>
+        <p:txBody>
+          <a:bodyPr/>
+          <a:p/>
+        </p:txBody>
       </p:sp>
       <p:sp>
         <p:nvSpPr>
@@ -8479,6 +9645,10 @@
             <a:prstDash val="solid"/>
           </a:ln>
         </p:spPr>
+        <p:txBody>
+          <a:bodyPr/>
+          <a:p/>
+        </p:txBody>
       </p:sp>
       <p:sp>
         <p:nvSpPr>
@@ -8617,6 +9787,10 @@
             <a:prstDash val="solid"/>
           </a:ln>
         </p:spPr>
+        <p:txBody>
+          <a:bodyPr/>
+          <a:p/>
+        </p:txBody>
       </p:sp>
       <p:sp>
         <p:nvSpPr>
@@ -8682,15 +9856,7 @@
               <a:buNone/>
             </a:pPr>
             <a:r>
-              <a:rPr lang="en-US" sz="1000" dirty="0">
-                <a:solidFill>
-                  <a:srgbClr val="94A3B8"/>
-                </a:solidFill>
-                <a:latin typeface="Arial" pitchFamily="34" charset="0"/>
-                <a:ea typeface="Arial" pitchFamily="34" charset="-122"/>
-                <a:cs typeface="Arial" pitchFamily="34" charset="-120"/>
-              </a:rPr>
-              <a:t>Slide 3 of 12  •  Technical &amp; Architecture Deep Dive</a:t>
+              <a:t>Slide 3 of 13  •  Technical &amp; Architecture Deep Dive</a:t>
             </a:r>
             <a:endParaRPr lang="en-US" sz="1000" dirty="0"/>
           </a:p>
@@ -8835,6 +10001,10 @@
             <a:prstDash val="solid"/>
           </a:ln>
         </p:spPr>
+        <p:txBody>
+          <a:bodyPr/>
+          <a:p/>
+        </p:txBody>
       </p:sp>
       <p:sp>
         <p:nvSpPr>
@@ -8938,6 +10108,10 @@
             <a:prstDash val="solid"/>
           </a:ln>
         </p:spPr>
+        <p:txBody>
+          <a:bodyPr/>
+          <a:p/>
+        </p:txBody>
       </p:sp>
       <p:sp>
         <p:nvSpPr>
@@ -8963,6 +10137,10 @@
             <a:prstDash val="solid"/>
           </a:ln>
         </p:spPr>
+        <p:txBody>
+          <a:bodyPr/>
+          <a:p/>
+        </p:txBody>
       </p:sp>
       <p:sp>
         <p:nvSpPr>
@@ -9183,6 +10361,10 @@
             <a:prstDash val="solid"/>
           </a:ln>
         </p:spPr>
+        <p:txBody>
+          <a:bodyPr/>
+          <a:p/>
+        </p:txBody>
       </p:sp>
       <p:sp>
         <p:nvSpPr>
@@ -9208,6 +10390,10 @@
             <a:prstDash val="solid"/>
           </a:ln>
         </p:spPr>
+        <p:txBody>
+          <a:bodyPr/>
+          <a:p/>
+        </p:txBody>
       </p:sp>
       <p:sp>
         <p:nvSpPr>
@@ -9428,6 +10614,10 @@
             <a:prstDash val="solid"/>
           </a:ln>
         </p:spPr>
+        <p:txBody>
+          <a:bodyPr/>
+          <a:p/>
+        </p:txBody>
       </p:sp>
       <p:sp>
         <p:nvSpPr>
@@ -9453,6 +10643,10 @@
             <a:prstDash val="solid"/>
           </a:ln>
         </p:spPr>
+        <p:txBody>
+          <a:bodyPr/>
+          <a:p/>
+        </p:txBody>
       </p:sp>
       <p:sp>
         <p:nvSpPr>
@@ -9673,6 +10867,10 @@
             <a:prstDash val="solid"/>
           </a:ln>
         </p:spPr>
+        <p:txBody>
+          <a:bodyPr/>
+          <a:p/>
+        </p:txBody>
       </p:sp>
       <p:sp>
         <p:nvSpPr>
@@ -9698,6 +10896,10 @@
             <a:prstDash val="solid"/>
           </a:ln>
         </p:spPr>
+        <p:txBody>
+          <a:bodyPr/>
+          <a:p/>
+        </p:txBody>
       </p:sp>
       <p:sp>
         <p:nvSpPr>
@@ -9918,6 +11120,10 @@
             <a:prstDash val="solid"/>
           </a:ln>
         </p:spPr>
+        <p:txBody>
+          <a:bodyPr/>
+          <a:p/>
+        </p:txBody>
       </p:sp>
       <p:sp>
         <p:nvSpPr>
@@ -9982,6 +11188,10 @@
             <a:prstDash val="solid"/>
           </a:ln>
         </p:spPr>
+        <p:txBody>
+          <a:bodyPr/>
+          <a:p/>
+        </p:txBody>
       </p:sp>
       <p:sp>
         <p:nvSpPr>
@@ -10127,6 +11337,10 @@
             <a:prstDash val="solid"/>
           </a:ln>
         </p:spPr>
+        <p:txBody>
+          <a:bodyPr/>
+          <a:p/>
+        </p:txBody>
       </p:sp>
       <p:sp>
         <p:nvSpPr>
@@ -10272,6 +11486,10 @@
             <a:prstDash val="solid"/>
           </a:ln>
         </p:spPr>
+        <p:txBody>
+          <a:bodyPr/>
+          <a:p/>
+        </p:txBody>
       </p:sp>
       <p:sp>
         <p:nvSpPr>
@@ -10449,6 +11667,10 @@
             <a:prstDash val="solid"/>
           </a:ln>
         </p:spPr>
+        <p:txBody>
+          <a:bodyPr/>
+          <a:p/>
+        </p:txBody>
       </p:sp>
       <p:sp>
         <p:nvSpPr>
@@ -10514,15 +11736,7 @@
               <a:buNone/>
             </a:pPr>
             <a:r>
-              <a:rPr lang="en-US" sz="1000" dirty="0">
-                <a:solidFill>
-                  <a:srgbClr val="94A3B8"/>
-                </a:solidFill>
-                <a:latin typeface="Arial" pitchFamily="34" charset="0"/>
-                <a:ea typeface="Arial" pitchFamily="34" charset="-122"/>
-                <a:cs typeface="Arial" pitchFamily="34" charset="-120"/>
-              </a:rPr>
-              <a:t>Slide 4 of 12  •  Technical &amp; Architecture Deep Dive</a:t>
+              <a:t>Slide 4 of 13  •  Technical &amp; Architecture Deep Dive</a:t>
             </a:r>
             <a:endParaRPr lang="en-US" sz="1000" dirty="0"/>
           </a:p>
@@ -10667,6 +11881,10 @@
             <a:prstDash val="solid"/>
           </a:ln>
         </p:spPr>
+        <p:txBody>
+          <a:bodyPr/>
+          <a:p/>
+        </p:txBody>
       </p:sp>
       <p:sp>
         <p:nvSpPr>
@@ -10770,6 +11988,10 @@
             <a:prstDash val="solid"/>
           </a:ln>
         </p:spPr>
+        <p:txBody>
+          <a:bodyPr/>
+          <a:p/>
+        </p:txBody>
       </p:sp>
       <p:sp>
         <p:nvSpPr>
@@ -10795,6 +12017,10 @@
             <a:prstDash val="solid"/>
           </a:ln>
         </p:spPr>
+        <p:txBody>
+          <a:bodyPr/>
+          <a:p/>
+        </p:txBody>
       </p:sp>
       <p:sp>
         <p:nvSpPr>
@@ -10901,6 +12127,10 @@
             <a:prstDash val="solid"/>
           </a:ln>
         </p:spPr>
+        <p:txBody>
+          <a:bodyPr/>
+          <a:p/>
+        </p:txBody>
       </p:sp>
       <p:sp>
         <p:nvSpPr>
@@ -11043,6 +12273,10 @@
             <a:prstDash val="solid"/>
           </a:ln>
         </p:spPr>
+        <p:txBody>
+          <a:bodyPr/>
+          <a:p/>
+        </p:txBody>
       </p:sp>
       <p:sp>
         <p:nvSpPr>
@@ -11185,6 +12419,10 @@
             <a:prstDash val="solid"/>
           </a:ln>
         </p:spPr>
+        <p:txBody>
+          <a:bodyPr/>
+          <a:p/>
+        </p:txBody>
       </p:sp>
       <p:sp>
         <p:nvSpPr>
@@ -11327,6 +12565,10 @@
             <a:prstDash val="solid"/>
           </a:ln>
         </p:spPr>
+        <p:txBody>
+          <a:bodyPr/>
+          <a:p/>
+        </p:txBody>
       </p:sp>
       <p:sp>
         <p:nvSpPr>
@@ -11469,6 +12711,10 @@
             <a:prstDash val="solid"/>
           </a:ln>
         </p:spPr>
+        <p:txBody>
+          <a:bodyPr/>
+          <a:p/>
+        </p:txBody>
       </p:sp>
       <p:sp>
         <p:nvSpPr>
@@ -11533,6 +12779,10 @@
             <a:prstDash val="solid"/>
           </a:ln>
         </p:spPr>
+        <p:txBody>
+          <a:bodyPr/>
+          <a:p/>
+        </p:txBody>
       </p:sp>
       <p:sp>
         <p:nvSpPr>
@@ -11639,6 +12889,10 @@
             <a:prstDash val="solid"/>
           </a:ln>
         </p:spPr>
+        <p:txBody>
+          <a:bodyPr/>
+          <a:p/>
+        </p:txBody>
       </p:sp>
       <p:sp>
         <p:nvSpPr>
@@ -11745,6 +12999,10 @@
             <a:prstDash val="solid"/>
           </a:ln>
         </p:spPr>
+        <p:txBody>
+          <a:bodyPr/>
+          <a:p/>
+        </p:txBody>
       </p:sp>
       <p:sp>
         <p:nvSpPr>
@@ -11851,6 +13109,10 @@
             <a:prstDash val="solid"/>
           </a:ln>
         </p:spPr>
+        <p:txBody>
+          <a:bodyPr/>
+          <a:p/>
+        </p:txBody>
       </p:sp>
       <p:sp>
         <p:nvSpPr>
@@ -11986,6 +13248,10 @@
             <a:prstDash val="solid"/>
           </a:ln>
         </p:spPr>
+        <p:txBody>
+          <a:bodyPr/>
+          <a:p/>
+        </p:txBody>
       </p:sp>
       <p:sp>
         <p:nvSpPr>
@@ -12051,15 +13317,7 @@
               <a:buNone/>
             </a:pPr>
             <a:r>
-              <a:rPr lang="en-US" sz="1000" dirty="0">
-                <a:solidFill>
-                  <a:srgbClr val="94A3B8"/>
-                </a:solidFill>
-                <a:latin typeface="Arial" pitchFamily="34" charset="0"/>
-                <a:ea typeface="Arial" pitchFamily="34" charset="-122"/>
-                <a:cs typeface="Arial" pitchFamily="34" charset="-120"/>
-              </a:rPr>
-              <a:t>Slide 5 of 12  •  Technical &amp; Architecture Deep Dive</a:t>
+              <a:t>Slide 5 of 13  •  Technical &amp; Architecture Deep Dive</a:t>
             </a:r>
             <a:endParaRPr lang="en-US" sz="1000" dirty="0"/>
           </a:p>
@@ -12088,17 +13346,12 @@
           <a:p>
             <a:pPr indent="0" marL="0">
               <a:buNone/>
-            </a:pPr>
-            <a:r>
-              <a:rPr lang="en-US" sz="1000" b="1" spc="120" kern="0" dirty="0">
-                <a:solidFill>
-                  <a:srgbClr val="4338CA"/>
-                </a:solidFill>
-                <a:latin typeface="Arial" pitchFamily="34" charset="0"/>
-                <a:ea typeface="Arial" pitchFamily="34" charset="-122"/>
-                <a:cs typeface="Arial" pitchFamily="34" charset="-120"/>
-              </a:rPr>
-              <a:t>PILLAR 2: PET SAFETY RADAR</a:t>
+              <a:defRPr>
+                <a:solidFill/>
+              </a:defRPr>
+            </a:pPr>
+            <a:r>
+              <a:t>PILLAR 2: MULTIMODAL PET SAFETY RADAR</a:t>
             </a:r>
             <a:endParaRPr lang="en-US" sz="1000" dirty="0"/>
           </a:p>
@@ -12127,17 +13380,12 @@
           <a:p>
             <a:pPr indent="0" marL="0">
               <a:buNone/>
-            </a:pPr>
-            <a:r>
-              <a:rPr lang="en-US" sz="2100" b="1" dirty="0">
-                <a:solidFill>
-                  <a:srgbClr val="0F172A"/>
-                </a:solidFill>
-                <a:latin typeface="Arial" pitchFamily="34" charset="0"/>
-                <a:ea typeface="Arial" pitchFamily="34" charset="-122"/>
-                <a:cs typeface="Arial" pitchFamily="34" charset="-120"/>
-              </a:rPr>
-              <a:t>Lost &amp; Found Radar: Visual &amp; Semantic Correlation</a:t>
+              <a:defRPr>
+                <a:solidFill/>
+              </a:defRPr>
+            </a:pPr>
+            <a:r>
+              <a:t>Lost &amp; Found Radar: Multimodal Vision &amp; Semantic Biometric Matching</a:t>
             </a:r>
             <a:endParaRPr lang="en-US" sz="2100" dirty="0"/>
           </a:p>
@@ -12204,6 +13452,10 @@
             <a:prstDash val="solid"/>
           </a:ln>
         </p:spPr>
+        <p:txBody>
+          <a:bodyPr/>
+          <a:p/>
+        </p:txBody>
       </p:sp>
       <p:sp>
         <p:nvSpPr>
@@ -12307,6 +13559,10 @@
             <a:prstDash val="solid"/>
           </a:ln>
         </p:spPr>
+        <p:txBody>
+          <a:bodyPr/>
+          <a:p/>
+        </p:txBody>
       </p:sp>
       <p:sp>
         <p:nvSpPr>
@@ -12449,6 +13705,10 @@
             <a:prstDash val="solid"/>
           </a:ln>
         </p:spPr>
+        <p:txBody>
+          <a:bodyPr/>
+          <a:p/>
+        </p:txBody>
       </p:sp>
       <p:sp>
         <p:nvSpPr>
@@ -12551,17 +13811,12 @@
           <a:p>
             <a:pPr indent="0" marL="0">
               <a:buNone/>
-            </a:pPr>
-            <a:r>
-              <a:rPr lang="en-US" sz="850" dirty="0">
-                <a:solidFill>
-                  <a:srgbClr val="64748B"/>
-                </a:solidFill>
-                <a:latin typeface="Arial" pitchFamily="34" charset="0"/>
-                <a:ea typeface="Arial" pitchFamily="34" charset="-122"/>
-                <a:cs typeface="Arial" pitchFamily="34" charset="-120"/>
-              </a:rPr>
-              <a:t>High-accuracy visual &amp; semantic embedding</a:t>
+              <a:defRPr>
+                <a:solidFill/>
+              </a:defRPr>
+            </a:pPr>
+            <a:r>
+              <a:t>Dual Vision Biometric &amp; Semantic Embedding</a:t>
             </a:r>
             <a:endParaRPr lang="en-US" sz="850" dirty="0"/>
           </a:p>
@@ -12591,6 +13846,10 @@
             <a:prstDash val="solid"/>
           </a:ln>
         </p:spPr>
+        <p:txBody>
+          <a:bodyPr/>
+          <a:p/>
+        </p:txBody>
       </p:sp>
       <p:sp>
         <p:nvSpPr>
@@ -12654,17 +13913,12 @@
           <a:p>
             <a:pPr indent="0" marL="0">
               <a:buNone/>
-            </a:pPr>
-            <a:r>
-              <a:rPr lang="en-US" sz="1300" b="1" dirty="0">
-                <a:solidFill>
-                  <a:srgbClr val="0F172A"/>
-                </a:solidFill>
-                <a:latin typeface="Arial" pitchFamily="34" charset="0"/>
-                <a:ea typeface="Arial" pitchFamily="34" charset="-122"/>
-                <a:cs typeface="Arial" pitchFamily="34" charset="-120"/>
-              </a:rPr>
-              <a:t>92.4% Benchmark</a:t>
+              <a:defRPr>
+                <a:solidFill/>
+              </a:defRPr>
+            </a:pPr>
+            <a:r>
+              <a:t>95.2% Benchmark</a:t>
             </a:r>
             <a:endParaRPr lang="en-US" sz="1300" dirty="0"/>
           </a:p>
@@ -12693,17 +13947,12 @@
           <a:p>
             <a:pPr indent="0" marL="0">
               <a:buNone/>
-            </a:pPr>
-            <a:r>
-              <a:rPr lang="en-US" sz="850" dirty="0">
-                <a:solidFill>
-                  <a:srgbClr val="64748B"/>
-                </a:solidFill>
-                <a:latin typeface="Arial" pitchFamily="34" charset="0"/>
-                <a:ea typeface="Arial" pitchFamily="34" charset="-122"/>
-                <a:cs typeface="Arial" pitchFamily="34" charset="-120"/>
-              </a:rPr>
-              <a:t>High precision on color, breed &amp; collar</a:t>
+              <a:defRPr>
+                <a:solidFill/>
+              </a:defRPr>
+            </a:pPr>
+            <a:r>
+              <a:t>Real-time Coat, Ear &amp; Collar Feature Extraction</a:t>
             </a:r>
             <a:endParaRPr lang="en-US" sz="850" dirty="0"/>
           </a:p>
@@ -12733,6 +13982,10 @@
             <a:prstDash val="solid"/>
           </a:ln>
         </p:spPr>
+        <p:txBody>
+          <a:bodyPr/>
+          <a:p/>
+        </p:txBody>
       </p:sp>
       <p:sp>
         <p:nvSpPr>
@@ -12875,6 +14128,10 @@
             <a:prstDash val="solid"/>
           </a:ln>
         </p:spPr>
+        <p:txBody>
+          <a:bodyPr/>
+          <a:p/>
+        </p:txBody>
       </p:sp>
       <p:sp>
         <p:nvSpPr>
@@ -12900,6 +14157,10 @@
             <a:prstDash val="solid"/>
           </a:ln>
         </p:spPr>
+        <p:txBody>
+          <a:bodyPr/>
+          <a:p/>
+        </p:txBody>
       </p:sp>
       <p:sp>
         <p:nvSpPr>
@@ -12924,17 +14185,12 @@
           <a:p>
             <a:pPr indent="0" marL="0">
               <a:buNone/>
-            </a:pPr>
-            <a:r>
-              <a:rPr lang="en-US" sz="950" b="1" dirty="0">
-                <a:solidFill>
-                  <a:srgbClr val="065F46"/>
-                </a:solidFill>
-                <a:latin typeface="Arial" pitchFamily="34" charset="0"/>
-                <a:ea typeface="Arial" pitchFamily="34" charset="-122"/>
-                <a:cs typeface="Arial" pitchFamily="34" charset="-120"/>
-              </a:rPr>
-              <a:t>🐕 VERIFIED CASE 1: ROCKY (GERMAN SHEPHERD)</a:t>
+              <a:defRPr>
+                <a:solidFill/>
+              </a:defRPr>
+            </a:pPr>
+            <a:r>
+              <a:t>🐕 VERIFIED CASE 1: PHOTO UPLOAD &amp; MATCH (ROCKY)</a:t>
             </a:r>
             <a:endParaRPr lang="en-US" sz="950" dirty="0"/>
           </a:p>
@@ -13002,17 +14258,12 @@
           <a:p>
             <a:pPr indent="0" marL="0">
               <a:buNone/>
-            </a:pPr>
-            <a:r>
-              <a:rPr lang="en-US" sz="950" i="1" dirty="0">
-                <a:solidFill>
-                  <a:srgbClr val="0F172A"/>
-                </a:solidFill>
-                <a:latin typeface="Arial" pitchFamily="34" charset="0"/>
-                <a:ea typeface="Arial" pitchFamily="34" charset="-122"/>
-                <a:cs typeface="Arial" pitchFamily="34" charset="-120"/>
-              </a:rPr>
-              <a:t>"Found a large black and tan dog near Banani Road 11. Wearing a worn red collar with brass ring. Friendly, responds to sit command."</a:t>
+              <a:defRPr>
+                <a:solidFill/>
+              </a:defRPr>
+            </a:pPr>
+            <a:r>
+              <a:t>"📸 Sighting Photo Attached + Notes: Spotted black &amp; tan dog near Banani Rd 11. Wearing worn red collar. Friendly demeanor."</a:t>
             </a:r>
             <a:endParaRPr lang="en-US" sz="950" dirty="0"/>
           </a:p>
@@ -13041,17 +14292,12 @@
           <a:p>
             <a:pPr indent="0" marL="0">
               <a:buNone/>
-            </a:pPr>
-            <a:r>
-              <a:rPr lang="en-US" sz="850" b="1" dirty="0">
-                <a:solidFill>
-                  <a:srgbClr val="10B981"/>
-                </a:solidFill>
-                <a:latin typeface="Arial" pitchFamily="34" charset="0"/>
-                <a:ea typeface="Arial" pitchFamily="34" charset="-122"/>
-                <a:cs typeface="Arial" pitchFamily="34" charset="-120"/>
-              </a:rPr>
-              <a:t>MAIRA VECTOR RAG MATCH RESULT:</a:t>
+              <a:defRPr>
+                <a:solidFill/>
+              </a:defRPr>
+            </a:pPr>
+            <a:r>
+              <a:t>MULTIMODAL AI VISION BIOMETRIC RESULT:</a:t>
             </a:r>
             <a:endParaRPr lang="en-US" sz="850" dirty="0"/>
           </a:p>
@@ -13197,17 +14443,12 @@
           <a:p>
             <a:pPr indent="0" marL="0">
               <a:buNone/>
-            </a:pPr>
-            <a:r>
-              <a:rPr lang="en-US" sz="900" dirty="0">
-                <a:solidFill>
-                  <a:srgbClr val="0F172A"/>
-                </a:solidFill>
-                <a:latin typeface="Arial" pitchFamily="34" charset="0"/>
-                <a:ea typeface="Arial" pitchFamily="34" charset="-122"/>
-                <a:cs typeface="Arial" pitchFamily="34" charset="-120"/>
-              </a:rPr>
-              <a:t>German Shepherd • Black &amp; Tan • Floppy Left Ear</a:t>
+              <a:defRPr>
+                <a:solidFill/>
+              </a:defRPr>
+            </a:pPr>
+            <a:r>
+              <a:t>German Shepherd • 🎨 Coat: Black &amp; Tan • 🐾 Ears: Pointed • 🏷️ Collar: Red</a:t>
             </a:r>
             <a:endParaRPr lang="en-US" sz="900" dirty="0"/>
           </a:p>
@@ -13431,17 +14672,12 @@
           <a:p>
             <a:pPr indent="0" marL="0">
               <a:buNone/>
-            </a:pPr>
-            <a:r>
-              <a:rPr lang="en-US" sz="900" dirty="0">
-                <a:solidFill>
-                  <a:srgbClr val="0F172A"/>
-                </a:solidFill>
-                <a:latin typeface="Arial" pitchFamily="34" charset="0"/>
-                <a:ea typeface="Arial" pitchFamily="34" charset="-122"/>
-                <a:cs typeface="Arial" pitchFamily="34" charset="-120"/>
-              </a:rPr>
-              <a:t>0.92 (High Vector Cosine Similarity)</a:t>
+              <a:defRPr>
+                <a:solidFill/>
+              </a:defRPr>
+            </a:pPr>
+            <a:r>
+              <a:t>0.95 (Visual Biometric &amp; Semantic Correlation)</a:t>
             </a:r>
             <a:endParaRPr lang="en-US" sz="900" dirty="0"/>
           </a:p>
@@ -13471,6 +14707,10 @@
             <a:prstDash val="solid"/>
           </a:ln>
         </p:spPr>
+        <p:txBody>
+          <a:bodyPr/>
+          <a:p/>
+        </p:txBody>
       </p:sp>
       <p:sp>
         <p:nvSpPr>
@@ -13496,6 +14736,10 @@
             <a:prstDash val="solid"/>
           </a:ln>
         </p:spPr>
+        <p:txBody>
+          <a:bodyPr/>
+          <a:p/>
+        </p:txBody>
       </p:sp>
       <p:sp>
         <p:nvSpPr>
@@ -13637,17 +14881,12 @@
           <a:p>
             <a:pPr indent="0" marL="0">
               <a:buNone/>
-            </a:pPr>
-            <a:r>
-              <a:rPr lang="en-US" sz="850" b="1" dirty="0">
-                <a:solidFill>
-                  <a:srgbClr val="4338CA"/>
-                </a:solidFill>
-                <a:latin typeface="Arial" pitchFamily="34" charset="0"/>
-                <a:ea typeface="Arial" pitchFamily="34" charset="-122"/>
-                <a:cs typeface="Arial" pitchFamily="34" charset="-120"/>
-              </a:rPr>
-              <a:t>MAIRA VECTOR RAG MATCH RESULT:</a:t>
+              <a:defRPr>
+                <a:solidFill/>
+              </a:defRPr>
+            </a:pPr>
+            <a:r>
+              <a:t>MULTIMODAL AI VISION BIOMETRIC RESULT:</a:t>
             </a:r>
             <a:endParaRPr lang="en-US" sz="850" dirty="0"/>
           </a:p>
@@ -14027,17 +15266,12 @@
           <a:p>
             <a:pPr indent="0" marL="0">
               <a:buNone/>
-            </a:pPr>
-            <a:r>
-              <a:rPr lang="en-US" sz="900" dirty="0">
-                <a:solidFill>
-                  <a:srgbClr val="0F172A"/>
-                </a:solidFill>
-                <a:latin typeface="Arial" pitchFamily="34" charset="0"/>
-                <a:ea typeface="Arial" pitchFamily="34" charset="-122"/>
-                <a:cs typeface="Arial" pitchFamily="34" charset="-120"/>
-              </a:rPr>
-              <a:t>0.92 (High Vector Cosine Similarity)</a:t>
+              <a:defRPr>
+                <a:solidFill/>
+              </a:defRPr>
+            </a:pPr>
+            <a:r>
+              <a:t>0.95 (Visual Biometric &amp; Semantic Correlation)</a:t>
             </a:r>
             <a:endParaRPr lang="en-US" sz="900" dirty="0"/>
           </a:p>
@@ -14099,6 +15333,10 @@
             <a:prstDash val="solid"/>
           </a:ln>
         </p:spPr>
+        <p:txBody>
+          <a:bodyPr/>
+          <a:p/>
+        </p:txBody>
       </p:sp>
       <p:sp>
         <p:nvSpPr>
@@ -14164,15 +15402,7 @@
               <a:buNone/>
             </a:pPr>
             <a:r>
-              <a:rPr lang="en-US" sz="1000" dirty="0">
-                <a:solidFill>
-                  <a:srgbClr val="94A3B8"/>
-                </a:solidFill>
-                <a:latin typeface="Arial" pitchFamily="34" charset="0"/>
-                <a:ea typeface="Arial" pitchFamily="34" charset="-122"/>
-                <a:cs typeface="Arial" pitchFamily="34" charset="-120"/>
-              </a:rPr>
-              <a:t>Slide 6 of 12  •  Technical &amp; Architecture Deep Dive</a:t>
+              <a:t>Slide 7 of 13  •  Technical &amp; Architecture Deep Dive</a:t>
             </a:r>
             <a:endParaRPr lang="en-US" sz="1000" dirty="0"/>
           </a:p>
@@ -14317,6 +15547,10 @@
             <a:prstDash val="solid"/>
           </a:ln>
         </p:spPr>
+        <p:txBody>
+          <a:bodyPr/>
+          <a:p/>
+        </p:txBody>
       </p:sp>
       <p:sp>
         <p:nvSpPr>
@@ -14420,6 +15654,10 @@
             <a:prstDash val="solid"/>
           </a:ln>
         </p:spPr>
+        <p:txBody>
+          <a:bodyPr/>
+          <a:p/>
+        </p:txBody>
       </p:sp>
       <p:sp>
         <p:nvSpPr>
@@ -14484,6 +15722,10 @@
             <a:prstDash val="solid"/>
           </a:ln>
         </p:spPr>
+        <p:txBody>
+          <a:bodyPr/>
+          <a:p/>
+        </p:txBody>
       </p:sp>
       <p:sp>
         <p:nvSpPr>
@@ -14665,6 +15907,10 @@
             <a:prstDash val="solid"/>
           </a:ln>
         </p:spPr>
+        <p:txBody>
+          <a:bodyPr/>
+          <a:p/>
+        </p:txBody>
       </p:sp>
       <p:sp>
         <p:nvSpPr>
@@ -14846,6 +16092,10 @@
             <a:prstDash val="solid"/>
           </a:ln>
         </p:spPr>
+        <p:txBody>
+          <a:bodyPr/>
+          <a:p/>
+        </p:txBody>
       </p:sp>
       <p:sp>
         <p:nvSpPr>
@@ -15027,6 +16277,10 @@
             <a:prstDash val="solid"/>
           </a:ln>
         </p:spPr>
+        <p:txBody>
+          <a:bodyPr/>
+          <a:p/>
+        </p:txBody>
       </p:sp>
       <p:sp>
         <p:nvSpPr>
@@ -15208,6 +16462,10 @@
             <a:prstDash val="solid"/>
           </a:ln>
         </p:spPr>
+        <p:txBody>
+          <a:bodyPr/>
+          <a:p/>
+        </p:txBody>
       </p:sp>
       <p:sp>
         <p:nvSpPr>
@@ -15272,6 +16530,10 @@
             <a:prstDash val="solid"/>
           </a:ln>
         </p:spPr>
+        <p:txBody>
+          <a:bodyPr/>
+          <a:p/>
+        </p:txBody>
       </p:sp>
       <p:sp>
         <p:nvSpPr>
@@ -15378,6 +16640,10 @@
             <a:prstDash val="solid"/>
           </a:ln>
         </p:spPr>
+        <p:txBody>
+          <a:bodyPr/>
+          <a:p/>
+        </p:txBody>
       </p:sp>
       <p:sp>
         <p:nvSpPr>
@@ -15484,6 +16750,10 @@
             <a:prstDash val="solid"/>
           </a:ln>
         </p:spPr>
+        <p:txBody>
+          <a:bodyPr/>
+          <a:p/>
+        </p:txBody>
       </p:sp>
       <p:sp>
         <p:nvSpPr>
@@ -15590,6 +16860,10 @@
             <a:prstDash val="solid"/>
           </a:ln>
         </p:spPr>
+        <p:txBody>
+          <a:bodyPr/>
+          <a:p/>
+        </p:txBody>
       </p:sp>
       <p:sp>
         <p:nvSpPr>
@@ -15728,6 +17002,10 @@
             <a:prstDash val="solid"/>
           </a:ln>
         </p:spPr>
+        <p:txBody>
+          <a:bodyPr/>
+          <a:p/>
+        </p:txBody>
       </p:sp>
       <p:sp>
         <p:nvSpPr>
@@ -15793,15 +17071,7 @@
               <a:buNone/>
             </a:pPr>
             <a:r>
-              <a:rPr lang="en-US" sz="1000" dirty="0">
-                <a:solidFill>
-                  <a:srgbClr val="94A3B8"/>
-                </a:solidFill>
-                <a:latin typeface="Arial" pitchFamily="34" charset="0"/>
-                <a:ea typeface="Arial" pitchFamily="34" charset="-122"/>
-                <a:cs typeface="Arial" pitchFamily="34" charset="-120"/>
-              </a:rPr>
-              <a:t>Slide 7 of 12  •  Technical &amp; Architecture Deep Dive</a:t>
+              <a:t>Slide 8 of 13  •  Technical &amp; Architecture Deep Dive</a:t>
             </a:r>
             <a:endParaRPr lang="en-US" sz="1000" dirty="0"/>
           </a:p>
@@ -15946,6 +17216,10 @@
             <a:prstDash val="solid"/>
           </a:ln>
         </p:spPr>
+        <p:txBody>
+          <a:bodyPr/>
+          <a:p/>
+        </p:txBody>
       </p:sp>
       <p:sp>
         <p:nvSpPr>
@@ -16049,6 +17323,10 @@
             <a:prstDash val="solid"/>
           </a:ln>
         </p:spPr>
+        <p:txBody>
+          <a:bodyPr/>
+          <a:p/>
+        </p:txBody>
       </p:sp>
       <p:sp>
         <p:nvSpPr>
@@ -16113,6 +17391,10 @@
             <a:prstDash val="solid"/>
           </a:ln>
         </p:spPr>
+        <p:txBody>
+          <a:bodyPr/>
+          <a:p/>
+        </p:txBody>
       </p:sp>
       <p:sp>
         <p:nvSpPr>
@@ -16219,6 +17501,10 @@
             <a:prstDash val="solid"/>
           </a:ln>
         </p:spPr>
+        <p:txBody>
+          <a:bodyPr/>
+          <a:p/>
+        </p:txBody>
       </p:sp>
       <p:sp>
         <p:nvSpPr>
@@ -16325,6 +17611,10 @@
             <a:prstDash val="solid"/>
           </a:ln>
         </p:spPr>
+        <p:txBody>
+          <a:bodyPr/>
+          <a:p/>
+        </p:txBody>
       </p:sp>
       <p:sp>
         <p:nvSpPr>
@@ -16431,6 +17721,10 @@
             <a:prstDash val="solid"/>
           </a:ln>
         </p:spPr>
+        <p:txBody>
+          <a:bodyPr/>
+          <a:p/>
+        </p:txBody>
       </p:sp>
       <p:sp>
         <p:nvSpPr>
@@ -16537,6 +17831,10 @@
             <a:prstDash val="solid"/>
           </a:ln>
         </p:spPr>
+        <p:txBody>
+          <a:bodyPr/>
+          <a:p/>
+        </p:txBody>
       </p:sp>
       <p:sp>
         <p:nvSpPr>
@@ -16601,6 +17899,10 @@
             <a:prstDash val="solid"/>
           </a:ln>
         </p:spPr>
+        <p:txBody>
+          <a:bodyPr/>
+          <a:p/>
+        </p:txBody>
       </p:sp>
       <p:sp>
         <p:nvSpPr>
@@ -16823,6 +18125,10 @@
             <a:prstDash val="solid"/>
           </a:ln>
         </p:spPr>
+        <p:txBody>
+          <a:bodyPr/>
+          <a:p/>
+        </p:txBody>
       </p:sp>
       <p:sp>
         <p:nvSpPr>
@@ -17110,6 +18416,10 @@
             <a:prstDash val="solid"/>
           </a:ln>
         </p:spPr>
+        <p:txBody>
+          <a:bodyPr/>
+          <a:p/>
+        </p:txBody>
       </p:sp>
       <p:sp>
         <p:nvSpPr>
@@ -17175,15 +18485,7 @@
               <a:buNone/>
             </a:pPr>
             <a:r>
-              <a:rPr lang="en-US" sz="1000" dirty="0">
-                <a:solidFill>
-                  <a:srgbClr val="94A3B8"/>
-                </a:solidFill>
-                <a:latin typeface="Arial" pitchFamily="34" charset="0"/>
-                <a:ea typeface="Arial" pitchFamily="34" charset="-122"/>
-                <a:cs typeface="Arial" pitchFamily="34" charset="-120"/>
-              </a:rPr>
-              <a:t>Slide 8 of 12  •  Technical &amp; Architecture Deep Dive</a:t>
+              <a:t>Slide 9 of 13  •  Technical &amp; Architecture Deep Dive</a:t>
             </a:r>
             <a:endParaRPr lang="en-US" sz="1000" dirty="0"/>
           </a:p>
@@ -17328,6 +18630,10 @@
             <a:prstDash val="solid"/>
           </a:ln>
         </p:spPr>
+        <p:txBody>
+          <a:bodyPr/>
+          <a:p/>
+        </p:txBody>
       </p:sp>
       <p:sp>
         <p:nvSpPr>
@@ -17431,6 +18737,10 @@
             <a:prstDash val="solid"/>
           </a:ln>
         </p:spPr>
+        <p:txBody>
+          <a:bodyPr/>
+          <a:p/>
+        </p:txBody>
       </p:sp>
       <p:sp>
         <p:nvSpPr>
@@ -17568,6 +18878,10 @@
             <a:prstDash val="solid"/>
           </a:ln>
         </p:spPr>
+        <p:txBody>
+          <a:bodyPr/>
+          <a:p/>
+        </p:txBody>
       </p:sp>
       <p:sp>
         <p:nvSpPr>
@@ -17833,6 +19147,10 @@
             <a:prstDash val="solid"/>
           </a:ln>
         </p:spPr>
+        <p:txBody>
+          <a:bodyPr/>
+          <a:p/>
+        </p:txBody>
       </p:sp>
       <p:sp>
         <p:nvSpPr>
@@ -17970,6 +19288,10 @@
             <a:prstDash val="solid"/>
           </a:ln>
         </p:spPr>
+        <p:txBody>
+          <a:bodyPr/>
+          <a:p/>
+        </p:txBody>
       </p:sp>
       <p:sp>
         <p:nvSpPr>
@@ -18235,6 +19557,10 @@
             <a:prstDash val="solid"/>
           </a:ln>
         </p:spPr>
+        <p:txBody>
+          <a:bodyPr/>
+          <a:p/>
+        </p:txBody>
       </p:sp>
       <p:sp>
         <p:nvSpPr>
@@ -18372,6 +19698,10 @@
             <a:prstDash val="solid"/>
           </a:ln>
         </p:spPr>
+        <p:txBody>
+          <a:bodyPr/>
+          <a:p/>
+        </p:txBody>
       </p:sp>
       <p:sp>
         <p:nvSpPr>
@@ -18637,6 +19967,10 @@
             <a:prstDash val="solid"/>
           </a:ln>
         </p:spPr>
+        <p:txBody>
+          <a:bodyPr/>
+          <a:p/>
+        </p:txBody>
       </p:sp>
       <p:sp>
         <p:nvSpPr>
@@ -19045,6 +20379,10 @@
             <a:prstDash val="solid"/>
           </a:ln>
         </p:spPr>
+        <p:txBody>
+          <a:bodyPr/>
+          <a:p/>
+        </p:txBody>
       </p:sp>
       <p:sp>
         <p:nvSpPr>
@@ -19110,15 +20448,7 @@
               <a:buNone/>
             </a:pPr>
             <a:r>
-              <a:rPr lang="en-US" sz="1000" dirty="0">
-                <a:solidFill>
-                  <a:srgbClr val="94A3B8"/>
-                </a:solidFill>
-                <a:latin typeface="Arial" pitchFamily="34" charset="0"/>
-                <a:ea typeface="Arial" pitchFamily="34" charset="-122"/>
-                <a:cs typeface="Arial" pitchFamily="34" charset="-120"/>
-              </a:rPr>
-              <a:t>Slide 9 of 12  •  Technical &amp; Architecture Deep Dive</a:t>
+              <a:t>Slide 10 of 13  •  Technical &amp; Architecture Deep Dive</a:t>
             </a:r>
             <a:endParaRPr lang="en-US" sz="1000" dirty="0"/>
           </a:p>
@@ -19263,6 +20593,10 @@
             <a:prstDash val="solid"/>
           </a:ln>
         </p:spPr>
+        <p:txBody>
+          <a:bodyPr/>
+          <a:p/>
+        </p:txBody>
       </p:sp>
       <p:sp>
         <p:nvSpPr>
@@ -19405,6 +20739,10 @@
             <a:prstDash val="solid"/>
           </a:ln>
         </p:spPr>
+        <p:txBody>
+          <a:bodyPr/>
+          <a:p/>
+        </p:txBody>
       </p:sp>
       <p:sp>
         <p:nvSpPr>
@@ -19511,6 +20849,10 @@
             <a:prstDash val="solid"/>
           </a:ln>
         </p:spPr>
+        <p:txBody>
+          <a:bodyPr/>
+          <a:p/>
+        </p:txBody>
       </p:sp>
       <p:sp>
         <p:nvSpPr>
@@ -19617,6 +20959,10 @@
             <a:prstDash val="solid"/>
           </a:ln>
         </p:spPr>
+        <p:txBody>
+          <a:bodyPr/>
+          <a:p/>
+        </p:txBody>
       </p:sp>
       <p:sp>
         <p:nvSpPr>
@@ -19723,6 +21069,10 @@
             <a:prstDash val="solid"/>
           </a:ln>
         </p:spPr>
+        <p:txBody>
+          <a:bodyPr/>
+          <a:p/>
+        </p:txBody>
       </p:sp>
       <p:sp>
         <p:nvSpPr>

</xml_diff>